<commit_message>
Final deck: 11 slides, appendix removed; drop superseded deck copies
Co-Authored-By: Claude Opus 5.5 <noreply@anthropic.com>
Claude-Session: https://claude.ai/code/session_017KdnwN2qyuF8wMBvTngErS
</commit_message>
<xml_diff>
--- a/ENTR_4501_Gate_2_deck_FINAL_Poppins.pptx
+++ b/ENTR_4501_Gate_2_deck_FINAL_Poppins.pptx
@@ -19,7 +19,6 @@
     <p:sldId id="264" r:id="rId15"/>
     <p:sldId id="265" r:id="rId16"/>
     <p:sldId id="267" r:id="rId27"/>
-    <p:sldId id="266" r:id="rId17"/>
   </p:sldIdLst>
   <p:sldSz cy="10287000" cx="18288000"/>
   <p:notesSz cx="6858000" cy="9144000"/>
@@ -1012,186 +1011,6 @@
       <p:sp>
         <p:nvSpPr>
           <p:cNvPr id="295" name="Google Shape;295;p10:notes"/>
-          <p:cNvSpPr txBox="1"/>
-          <p:nvPr>
-            <p:ph idx="12" type="sldNum"/>
-          </p:nvPr>
-        </p:nvSpPr>
-        <p:spPr>
-          <a:xfrm>
-            <a:off x="0" y="0"/>
-            <a:ext cx="3000000" cy="3000000"/>
-          </a:xfrm>
-          <a:prstGeom prst="rect">
-            <a:avLst/>
-          </a:prstGeom>
-          <a:noFill/>
-          <a:ln>
-            <a:noFill/>
-          </a:ln>
-        </p:spPr>
-        <p:txBody>
-          <a:bodyPr anchorCtr="0" anchor="ctr" bIns="91425" lIns="91425" spcFirstLastPara="1" rIns="91425" wrap="square" tIns="91425">
-            <a:noAutofit/>
-          </a:bodyPr>
-          <a:lstStyle/>
-          <a:p>
-            <a:pPr indent="0" lvl="0" marL="0" rtl="0" algn="l">
-              <a:spcBef>
-                <a:spcPts val="0"/>
-              </a:spcBef>
-              <a:spcAft>
-                <a:spcPts val="0"/>
-              </a:spcAft>
-              <a:buNone/>
-            </a:pPr>
-            <a:r>
-              <a:t/>
-            </a:r>
-            <a:endParaRPr/>
-          </a:p>
-        </p:txBody>
-      </p:sp>
-    </p:spTree>
-  </p:cSld>
-  <p:clrMapOvr>
-    <a:masterClrMapping/>
-  </p:clrMapOvr>
-</p:notes>
-</file>
-
-<file path=ppt/notesSlides/notesSlide11.xml><?xml version="1.0" encoding="utf-8"?>
-<p:notes xmlns:a="http://schemas.openxmlformats.org/drawingml/2006/main" xmlns:r="http://schemas.openxmlformats.org/officeDocument/2006/relationships" xmlns:mc="http://schemas.openxmlformats.org/markup-compatibility/2006" xmlns:mv="urn:schemas-microsoft-com:mac:vml" xmlns:p="http://schemas.openxmlformats.org/presentationml/2006/main" xmlns:c="http://schemas.openxmlformats.org/drawingml/2006/chart" xmlns:dgm="http://schemas.openxmlformats.org/drawingml/2006/diagram" xmlns:o="urn:schemas-microsoft-com:office:office" xmlns:v="urn:schemas-microsoft-com:vml" xmlns:pvml="urn:schemas-microsoft-com:office:powerpoint" xmlns:com="http://schemas.openxmlformats.org/drawingml/2006/compatibility" xmlns:p14="http://schemas.microsoft.com/office/powerpoint/2010/main" xmlns:p15="http://schemas.microsoft.com/office/powerpoint/2012/main" xmlns:ahyp="http://schemas.microsoft.com/office/drawing/2018/hyperlinkcolor" showMasterPhAnim="0" showMasterSp="0">
-  <p:cSld>
-    <p:spTree>
-      <p:nvGrpSpPr>
-        <p:cNvPr id="313" name="Shape 313"/>
-        <p:cNvGrpSpPr/>
-        <p:nvPr/>
-      </p:nvGrpSpPr>
-      <p:grpSpPr>
-        <a:xfrm>
-          <a:off x="0" y="0"/>
-          <a:ext cx="0" cy="0"/>
-          <a:chOff x="0" y="0"/>
-          <a:chExt cx="0" cy="0"/>
-        </a:xfrm>
-      </p:grpSpPr>
-      <p:sp>
-        <p:nvSpPr>
-          <p:cNvPr id="314" name="Google Shape;314;p11:notes"/>
-          <p:cNvSpPr/>
-          <p:nvPr>
-            <p:ph idx="2" type="sldImg"/>
-          </p:nvPr>
-        </p:nvSpPr>
-        <p:spPr>
-          <a:xfrm>
-            <a:off x="0" y="0"/>
-            <a:ext cx="3000000" cy="3000000"/>
-          </a:xfrm>
-          <a:custGeom>
-            <a:rect b="b" l="l" r="r" t="t"/>
-            <a:pathLst>
-              <a:path extrusionOk="0" h="120000" w="120000">
-                <a:moveTo>
-                  <a:pt x="0" y="0"/>
-                </a:moveTo>
-                <a:lnTo>
-                  <a:pt x="120000" y="0"/>
-                </a:lnTo>
-                <a:lnTo>
-                  <a:pt x="120000" y="120000"/>
-                </a:lnTo>
-                <a:lnTo>
-                  <a:pt x="0" y="120000"/>
-                </a:lnTo>
-                <a:close/>
-              </a:path>
-            </a:pathLst>
-          </a:custGeom>
-          <a:noFill/>
-          <a:ln>
-            <a:noFill/>
-          </a:ln>
-        </p:spPr>
-      </p:sp>
-      <p:sp>
-        <p:nvSpPr>
-          <p:cNvPr id="315" name="Google Shape;315;p11:notes"/>
-          <p:cNvSpPr txBox="1"/>
-          <p:nvPr>
-            <p:ph idx="1" type="body"/>
-          </p:nvPr>
-        </p:nvSpPr>
-        <p:spPr>
-          <a:xfrm>
-            <a:off x="0" y="0"/>
-            <a:ext cx="3000000" cy="3000000"/>
-          </a:xfrm>
-          <a:prstGeom prst="rect">
-            <a:avLst/>
-          </a:prstGeom>
-          <a:noFill/>
-          <a:ln>
-            <a:noFill/>
-          </a:ln>
-        </p:spPr>
-        <p:txBody>
-          <a:bodyPr anchorCtr="0" anchor="t" bIns="45700" lIns="91425" spcFirstLastPara="1" rIns="91425" wrap="square" tIns="45700">
-            <a:noAutofit/>
-          </a:bodyPr>
-          <a:lstStyle/>
-          <a:p>
-            <a:pPr indent="0" lvl="0" marL="0" rtl="0" algn="l">
-              <a:spcBef>
-                <a:spcPts val="0"/>
-              </a:spcBef>
-              <a:spcAft>
-                <a:spcPts val="600"/>
-              </a:spcAft>
-              <a:buNone/>
-            </a:pPr>
-            <a:r>
-              <a:rPr lang="en-US"/>
-              <a:t>If someone asks where our prices come from, this is it.</a:t>
-            </a:r>
-          </a:p>
-          <a:p>
-            <a:pPr indent="0" lvl="0" marL="0" rtl="0" algn="l">
-              <a:spcBef>
-                <a:spcPts val="0"/>
-              </a:spcBef>
-              <a:spcAft>
-                <a:spcPts val="600"/>
-              </a:spcAft>
-              <a:buNone/>
-            </a:pPr>
-            <a:r>
-              <a:rPr lang="en-US"/>
-              <a:t>Businesses pay $288,000 in Year 5: $156,000 for diners we send, $54,000 for bookings and $78,000 for area insights for chains. The 90 cents is under OpenTable’s $1 to $1.50, bookings are a quarter of Tabelog’s rate, and chains pay a quarter of Placer.ai’s price.</a:t>
-            </a:r>
-          </a:p>
-          <a:p>
-            <a:pPr indent="0" lvl="0" marL="0" rtl="0" algn="l">
-              <a:spcBef>
-                <a:spcPts val="0"/>
-              </a:spcBef>
-              <a:spcAft>
-                <a:spcPts val="600"/>
-              </a:spcAft>
-              <a:buNone/>
-            </a:pPr>
-            <a:r>
-              <a:rPr lang="en-US"/>
-              <a:t>The membership brings in $67,000, from about 0.3% of our average Year 5 users. That’s the same share as Tabelog.</a:t>
-            </a:r>
-          </a:p>
-        </p:txBody>
-      </p:sp>
-      <p:sp>
-        <p:nvSpPr>
-          <p:cNvPr id="316" name="Google Shape;316;p11:notes"/>
           <p:cNvSpPr txBox="1"/>
           <p:nvPr>
             <p:ph idx="12" type="sldNum"/>
@@ -14726,905 +14545,6 @@
               <a:t>$74K in grants plus $166K from angels: $240K in all. At $356K of Year 5 revenue we're too small for venture funds, so the angels' way out is a sale to a bigger platform or a card company, as Resy sold to American Express.</a:t>
             </a:r>
             <a:endParaRPr/>
-          </a:p>
-        </p:txBody>
-      </p:sp>
-    </p:spTree>
-  </p:cSld>
-  <p:clrMapOvr>
-    <a:masterClrMapping/>
-  </p:clrMapOvr>
-</p:sld>
-</file>
-
-<file path=ppt/slides/slide11.xml><?xml version="1.0" encoding="utf-8"?>
-<p:sld xmlns:a="http://schemas.openxmlformats.org/drawingml/2006/main" xmlns:r="http://schemas.openxmlformats.org/officeDocument/2006/relationships" xmlns:mc="http://schemas.openxmlformats.org/markup-compatibility/2006" xmlns:mv="urn:schemas-microsoft-com:mac:vml" xmlns:p="http://schemas.openxmlformats.org/presentationml/2006/main" xmlns:c="http://schemas.openxmlformats.org/drawingml/2006/chart" xmlns:dgm="http://schemas.openxmlformats.org/drawingml/2006/diagram" xmlns:o="urn:schemas-microsoft-com:office:office" xmlns:v="urn:schemas-microsoft-com:vml" xmlns:pvml="urn:schemas-microsoft-com:office:powerpoint" xmlns:com="http://schemas.openxmlformats.org/drawingml/2006/compatibility" xmlns:p14="http://schemas.microsoft.com/office/powerpoint/2010/main" xmlns:p15="http://schemas.microsoft.com/office/powerpoint/2012/main" xmlns:ahyp="http://schemas.microsoft.com/office/drawing/2018/hyperlinkcolor">
-  <p:cSld>
-    <p:spTree>
-      <p:nvGrpSpPr>
-        <p:cNvPr id="317" name="Shape 317"/>
-        <p:cNvGrpSpPr/>
-        <p:nvPr/>
-      </p:nvGrpSpPr>
-      <p:grpSpPr>
-        <a:xfrm>
-          <a:off x="0" y="0"/>
-          <a:ext cx="0" cy="0"/>
-          <a:chOff x="0" y="0"/>
-          <a:chExt cx="0" cy="0"/>
-        </a:xfrm>
-      </p:grpSpPr>
-      <p:sp>
-        <p:nvSpPr>
-          <p:cNvPr id="318" name="Google Shape;318;p11"/>
-          <p:cNvSpPr txBox="1"/>
-          <p:nvPr/>
-        </p:nvSpPr>
-        <p:spPr>
-          <a:xfrm>
-            <a:off x="822960" y="685800"/>
-            <a:ext cx="10972800" cy="411480"/>
-          </a:xfrm>
-          <a:prstGeom prst="rect">
-            <a:avLst/>
-          </a:prstGeom>
-          <a:noFill/>
-          <a:ln>
-            <a:noFill/>
-          </a:ln>
-        </p:spPr>
-        <p:txBody>
-          <a:bodyPr anchorCtr="0" anchor="t" bIns="0" lIns="0" spcFirstLastPara="1" rIns="0" wrap="square" tIns="0">
-            <a:spAutoFit/>
-          </a:bodyPr>
-          <a:lstStyle/>
-          <a:p>
-            <a:pPr indent="0" lvl="0" marL="0" marR="0" rtl="0" algn="l">
-              <a:lnSpc>
-                <a:spcPct val="110000"/>
-              </a:lnSpc>
-              <a:spcBef>
-                <a:spcPts val="0"/>
-              </a:spcBef>
-              <a:spcAft>
-                <a:spcPts val="0"/>
-              </a:spcAft>
-              <a:buNone/>
-            </a:pPr>
-            <a:r>
-              <a:rPr b="0" i="0" lang="en-US" sz="1800" u="none" cap="none" strike="noStrike">
-                <a:solidFill>
-                  <a:srgbClr val="6F6B34"/>
-                </a:solidFill>
-                <a:latin typeface="Poppins"/>
-                <a:ea typeface="Poppins"/>
-                <a:cs typeface="Poppins"/>
-                <a:sym typeface="Poppins"/>
-              </a:rPr>
-              <a:t>Appendix</a:t>
-            </a:r>
-            <a:endParaRPr/>
-          </a:p>
-        </p:txBody>
-      </p:sp>
-      <p:sp>
-        <p:nvSpPr>
-          <p:cNvPr id="319" name="Google Shape;319;p11"/>
-          <p:cNvSpPr txBox="1"/>
-          <p:nvPr/>
-        </p:nvSpPr>
-        <p:spPr>
-          <a:xfrm>
-            <a:off x="16093440" y="685800"/>
-            <a:ext cx="1371600" cy="365760"/>
-          </a:xfrm>
-          <a:prstGeom prst="rect">
-            <a:avLst/>
-          </a:prstGeom>
-          <a:noFill/>
-          <a:ln>
-            <a:noFill/>
-          </a:ln>
-        </p:spPr>
-        <p:txBody>
-          <a:bodyPr anchorCtr="0" anchor="t" bIns="0" lIns="0" spcFirstLastPara="1" rIns="0" wrap="square" tIns="0">
-            <a:spAutoFit/>
-          </a:bodyPr>
-          <a:lstStyle/>
-          <a:p>
-            <a:pPr indent="0" lvl="0" marL="0" marR="0" rtl="0" algn="r">
-              <a:lnSpc>
-                <a:spcPct val="110000"/>
-              </a:lnSpc>
-              <a:spcBef>
-                <a:spcPts val="0"/>
-              </a:spcBef>
-              <a:spcAft>
-                <a:spcPts val="0"/>
-              </a:spcAft>
-              <a:buNone/>
-            </a:pPr>
-            <a:r>
-              <a:t/>
-            </a:r>
-            <a:endParaRPr b="0" i="0" sz="1800" u="none" cap="none" strike="noStrike">
-              <a:solidFill>
-                <a:schemeClr val="dk1"/>
-              </a:solidFill>
-              <a:latin typeface="Calibri"/>
-              <a:ea typeface="Calibri"/>
-              <a:cs typeface="Calibri"/>
-              <a:sym typeface="Calibri"/>
-            </a:endParaRPr>
-          </a:p>
-        </p:txBody>
-      </p:sp>
-      <p:sp>
-        <p:nvSpPr>
-          <p:cNvPr id="320" name="Google Shape;320;p11"/>
-          <p:cNvSpPr txBox="1"/>
-          <p:nvPr/>
-        </p:nvSpPr>
-        <p:spPr>
-          <a:xfrm>
-            <a:off x="822960" y="1234440"/>
-            <a:ext cx="15087600" cy="2011680"/>
-          </a:xfrm>
-          <a:prstGeom prst="rect">
-            <a:avLst/>
-          </a:prstGeom>
-          <a:noFill/>
-          <a:ln>
-            <a:noFill/>
-          </a:ln>
-        </p:spPr>
-        <p:txBody>
-          <a:bodyPr anchorCtr="0" anchor="t" bIns="0" lIns="0" spcFirstLastPara="1" rIns="0" wrap="square" tIns="0">
-            <a:spAutoFit/>
-          </a:bodyPr>
-          <a:lstStyle/>
-          <a:p>
-            <a:pPr indent="0" lvl="0" marL="0" marR="0" rtl="0" algn="l">
-              <a:lnSpc>
-                <a:spcPct val="108000"/>
-              </a:lnSpc>
-              <a:spcBef>
-                <a:spcPts val="0"/>
-              </a:spcBef>
-              <a:spcAft>
-                <a:spcPts val="0"/>
-              </a:spcAft>
-              <a:buNone/>
-            </a:pPr>
-            <a:r>
-              <a:rPr b="0" i="0" lang="en-US" sz="4400" u="none" cap="none" strike="noStrike">
-                <a:solidFill>
-                  <a:srgbClr val="000000"/>
-                </a:solidFill>
-                <a:latin typeface="Poppins"/>
-                <a:ea typeface="Poppins"/>
-                <a:cs typeface="Poppins"/>
-                <a:sym typeface="Poppins"/>
-              </a:rPr>
-              <a:t>Two sides pay, and every price starts from a real company’s number. </a:t>
-            </a:r>
-            <a:r>
-              <a:rPr b="0" i="0" lang="en-US" sz="4400" u="none" cap="none" strike="noStrike">
-                <a:solidFill>
-                  <a:srgbClr val="595959"/>
-                </a:solidFill>
-                <a:latin typeface="Poppins"/>
-                <a:ea typeface="Poppins"/>
-                <a:cs typeface="Poppins"/>
-                <a:sym typeface="Poppins"/>
-              </a:rPr>
-              <a:t>How many we sell is our guess.</a:t>
-            </a:r>
-            <a:endParaRPr/>
-          </a:p>
-        </p:txBody>
-      </p:sp>
-      <p:sp>
-        <p:nvSpPr>
-          <p:cNvPr id="321" name="Google Shape;321;p11"/>
-          <p:cNvSpPr txBox="1"/>
-          <p:nvPr/>
-        </p:nvSpPr>
-        <p:spPr>
-          <a:xfrm>
-            <a:off x="822960" y="9555480"/>
-            <a:ext cx="16642080" cy="548640"/>
-          </a:xfrm>
-          <a:prstGeom prst="rect">
-            <a:avLst/>
-          </a:prstGeom>
-          <a:noFill/>
-          <a:ln>
-            <a:noFill/>
-          </a:ln>
-        </p:spPr>
-        <p:txBody>
-          <a:bodyPr anchorCtr="0" anchor="t" bIns="0" lIns="0" spcFirstLastPara="1" rIns="0" wrap="square" tIns="0">
-            <a:spAutoFit/>
-          </a:bodyPr>
-          <a:lstStyle/>
-          <a:p>
-            <a:pPr indent="0" lvl="0" marL="0" marR="0" rtl="0" algn="l">
-              <a:lnSpc>
-                <a:spcPct val="110000"/>
-              </a:lnSpc>
-              <a:spcBef>
-                <a:spcPts val="0"/>
-              </a:spcBef>
-              <a:spcAft>
-                <a:spcPts val="0"/>
-              </a:spcAft>
-              <a:buNone/>
-            </a:pPr>
-            <a:r>
-              <a:rPr b="0" i="0" lang="en-US" sz="1400" u="none" cap="none" strike="noStrike">
-                <a:solidFill>
-                  <a:srgbClr val="595959"/>
-                </a:solidFill>
-                <a:latin typeface="Roboto Mono"/>
-                <a:ea typeface="Roboto Mono"/>
-                <a:cs typeface="Roboto Mono"/>
-                <a:sym typeface="Roboto Mono"/>
-              </a:rPr>
-              <a:t>OpenTable pricing via Eat App, 2026. TechCrunch, Aug 2024 (Placer.ai). Kakaku.com results, Nov 2025 (Tabelog).</a:t>
-            </a:r>
-            <a:endParaRPr/>
-          </a:p>
-        </p:txBody>
-      </p:sp>
-      <p:sp>
-        <p:nvSpPr>
-          <p:cNvPr id="341" name="Google Shape;341;p11"/>
-          <p:cNvSpPr txBox="1"/>
-          <p:nvPr/>
-        </p:nvSpPr>
-        <p:spPr>
-          <a:xfrm>
-            <a:off x="822960" y="3657600"/>
-            <a:ext cx="3931920" cy="365760"/>
-          </a:xfrm>
-          <a:prstGeom prst="rect">
-            <a:avLst/>
-          </a:prstGeom>
-          <a:noFill/>
-          <a:ln>
-            <a:noFill/>
-          </a:ln>
-        </p:spPr>
-        <p:txBody>
-          <a:bodyPr anchorCtr="0" anchor="t" bIns="0" lIns="0" spcFirstLastPara="1" rIns="0" wrap="square" tIns="0">
-            <a:spAutoFit/>
-          </a:bodyPr>
-          <a:lstStyle/>
-          <a:p>
-            <a:pPr indent="0" lvl="0" marL="0" marR="0" rtl="0" algn="l">
-              <a:lnSpc>
-                <a:spcPct val="110000"/>
-              </a:lnSpc>
-              <a:spcBef>
-                <a:spcPts val="0"/>
-              </a:spcBef>
-              <a:spcAft>
-                <a:spcPts val="0"/>
-              </a:spcAft>
-              <a:buNone/>
-            </a:pPr>
-            <a:r>
-              <a:rPr b="1" i="0" lang="en-US" sz="2400" u="none" cap="none" strike="noStrike">
-                <a:solidFill>
-                  <a:srgbClr val="6F6B34"/>
-                </a:solidFill>
-                <a:latin typeface="Poppins"/>
-                <a:ea typeface="Poppins"/>
-                <a:cs typeface="Poppins"/>
-                <a:sym typeface="Poppins"/>
-              </a:rPr>
-              <a:t>Stream</a:t>
-            </a:r>
-            <a:endParaRPr/>
-          </a:p>
-        </p:txBody>
-      </p:sp>
-      <p:sp>
-        <p:nvSpPr>
-          <p:cNvPr id="322" name="Google Shape;322;p11"/>
-          <p:cNvSpPr txBox="1"/>
-          <p:nvPr/>
-        </p:nvSpPr>
-        <p:spPr>
-          <a:xfrm>
-            <a:off x="4937760" y="3657600"/>
-            <a:ext cx="1737360" cy="365760"/>
-          </a:xfrm>
-          <a:prstGeom prst="rect">
-            <a:avLst/>
-          </a:prstGeom>
-          <a:noFill/>
-          <a:ln>
-            <a:noFill/>
-          </a:ln>
-        </p:spPr>
-        <p:txBody>
-          <a:bodyPr anchorCtr="0" anchor="t" bIns="0" lIns="0" spcFirstLastPara="1" rIns="0" wrap="square" tIns="0">
-            <a:spAutoFit/>
-          </a:bodyPr>
-          <a:lstStyle/>
-          <a:p>
-            <a:pPr indent="0" lvl="0" marL="0" marR="0" rtl="0" algn="l">
-              <a:lnSpc>
-                <a:spcPct val="110000"/>
-              </a:lnSpc>
-              <a:spcBef>
-                <a:spcPts val="0"/>
-              </a:spcBef>
-              <a:spcAft>
-                <a:spcPts val="0"/>
-              </a:spcAft>
-              <a:buNone/>
-            </a:pPr>
-            <a:r>
-              <a:rPr b="1" i="0" lang="en-US" sz="2400" u="none" cap="none" strike="noStrike">
-                <a:solidFill>
-                  <a:srgbClr val="6F6B34"/>
-                </a:solidFill>
-                <a:latin typeface="Poppins"/>
-                <a:ea typeface="Poppins"/>
-                <a:cs typeface="Poppins"/>
-                <a:sym typeface="Poppins"/>
-              </a:rPr>
-              <a:t>Year 5</a:t>
-            </a:r>
-            <a:endParaRPr/>
-          </a:p>
-        </p:txBody>
-      </p:sp>
-      <p:sp>
-        <p:nvSpPr>
-          <p:cNvPr id="323" name="Google Shape;323;p11"/>
-          <p:cNvSpPr txBox="1"/>
-          <p:nvPr/>
-        </p:nvSpPr>
-        <p:spPr>
-          <a:xfrm>
-            <a:off x="6949440" y="3657600"/>
-            <a:ext cx="10515600" cy="365760"/>
-          </a:xfrm>
-          <a:prstGeom prst="rect">
-            <a:avLst/>
-          </a:prstGeom>
-          <a:noFill/>
-          <a:ln>
-            <a:noFill/>
-          </a:ln>
-        </p:spPr>
-        <p:txBody>
-          <a:bodyPr anchorCtr="0" anchor="t" bIns="0" lIns="0" spcFirstLastPara="1" rIns="0" wrap="square" tIns="0">
-            <a:spAutoFit/>
-          </a:bodyPr>
-          <a:lstStyle/>
-          <a:p>
-            <a:pPr indent="0" lvl="0" marL="0" marR="0" rtl="0" algn="l">
-              <a:lnSpc>
-                <a:spcPct val="110000"/>
-              </a:lnSpc>
-              <a:spcBef>
-                <a:spcPts val="0"/>
-              </a:spcBef>
-              <a:spcAft>
-                <a:spcPts val="0"/>
-              </a:spcAft>
-              <a:buNone/>
-            </a:pPr>
-            <a:r>
-              <a:rPr b="1" i="0" lang="en-US" sz="2400" u="none" cap="none" strike="noStrike">
-                <a:solidFill>
-                  <a:srgbClr val="6F6B34"/>
-                </a:solidFill>
-                <a:latin typeface="Poppins"/>
-                <a:ea typeface="Poppins"/>
-                <a:cs typeface="Poppins"/>
-                <a:sym typeface="Poppins"/>
-              </a:rPr>
-              <a:t>What they pay for and why</a:t>
-            </a:r>
-            <a:endParaRPr/>
-          </a:p>
-        </p:txBody>
-      </p:sp>
-      <p:sp>
-        <p:nvSpPr>
-          <p:cNvPr id="324" name="Google Shape;324;p11"/>
-          <p:cNvSpPr/>
-          <p:nvPr/>
-        </p:nvSpPr>
-        <p:spPr>
-          <a:xfrm>
-            <a:off x="822960" y="4151376"/>
-            <a:ext cx="16642080" cy="10972"/>
-          </a:xfrm>
-          <a:prstGeom prst="rect">
-            <a:avLst/>
-          </a:prstGeom>
-          <a:solidFill>
-            <a:srgbClr val="D9D9D9"/>
-          </a:solidFill>
-          <a:ln>
-            <a:noFill/>
-          </a:ln>
-          <a:effectLst>
-            <a:outerShdw blurRad="40000" rotWithShape="0" dir="5400000" dist="23000">
-              <a:srgbClr val="000000">
-                <a:alpha val="34902"/>
-              </a:srgbClr>
-            </a:outerShdw>
-          </a:effectLst>
-        </p:spPr>
-        <p:txBody>
-          <a:bodyPr anchorCtr="0" anchor="ctr" bIns="45700" lIns="91425" spcFirstLastPara="1" rIns="91425" wrap="square" tIns="45700">
-            <a:noAutofit/>
-          </a:bodyPr>
-          <a:lstStyle/>
-          <a:p>
-            <a:pPr indent="0" lvl="0" marL="0" marR="0" rtl="0" algn="ctr">
-              <a:spcBef>
-                <a:spcPts val="0"/>
-              </a:spcBef>
-              <a:spcAft>
-                <a:spcPts val="0"/>
-              </a:spcAft>
-              <a:buNone/>
-            </a:pPr>
-            <a:r>
-              <a:t/>
-            </a:r>
-            <a:endParaRPr b="0" i="0" sz="1800" u="none" cap="none" strike="noStrike">
-              <a:solidFill>
-                <a:schemeClr val="dk1"/>
-              </a:solidFill>
-              <a:latin typeface="Calibri"/>
-              <a:ea typeface="Calibri"/>
-              <a:cs typeface="Calibri"/>
-              <a:sym typeface="Calibri"/>
-            </a:endParaRPr>
-          </a:p>
-        </p:txBody>
-      </p:sp>
-      <p:sp>
-        <p:nvSpPr>
-          <p:cNvPr id="325" name="Google Shape;325;p11"/>
-          <p:cNvSpPr txBox="1"/>
-          <p:nvPr/>
-        </p:nvSpPr>
-        <p:spPr>
-          <a:xfrm>
-            <a:off x="822960" y="4343400"/>
-            <a:ext cx="3931920" cy="548640"/>
-          </a:xfrm>
-          <a:prstGeom prst="rect">
-            <a:avLst/>
-          </a:prstGeom>
-          <a:noFill/>
-          <a:ln>
-            <a:noFill/>
-          </a:ln>
-        </p:spPr>
-        <p:txBody>
-          <a:bodyPr anchorCtr="0" anchor="t" bIns="0" lIns="0" spcFirstLastPara="1" rIns="0" wrap="square" tIns="0">
-            <a:spAutoFit/>
-          </a:bodyPr>
-          <a:lstStyle/>
-          <a:p>
-            <a:pPr indent="0" lvl="0" marL="0" marR="0" rtl="0" algn="l">
-              <a:lnSpc>
-                <a:spcPct val="110000"/>
-              </a:lnSpc>
-              <a:spcBef>
-                <a:spcPts val="0"/>
-              </a:spcBef>
-              <a:spcAft>
-                <a:spcPts val="0"/>
-              </a:spcAft>
-              <a:buNone/>
-            </a:pPr>
-            <a:r>
-              <a:rPr b="0" i="0" lang="en-US" sz="2400" u="none" cap="none" strike="noStrike">
-                <a:solidFill>
-                  <a:srgbClr val="000000"/>
-                </a:solidFill>
-                <a:latin typeface="Poppins"/>
-                <a:ea typeface="Poppins"/>
-                <a:cs typeface="Poppins"/>
-                <a:sym typeface="Poppins"/>
-              </a:rPr>
-              <a:t>Businesses</a:t>
-            </a:r>
-            <a:endParaRPr/>
-          </a:p>
-        </p:txBody>
-      </p:sp>
-      <p:sp>
-        <p:nvSpPr>
-          <p:cNvPr id="326" name="Google Shape;326;p11"/>
-          <p:cNvSpPr txBox="1"/>
-          <p:nvPr/>
-        </p:nvSpPr>
-        <p:spPr>
-          <a:xfrm>
-            <a:off x="4937760" y="4343400"/>
-            <a:ext cx="1737360" cy="548640"/>
-          </a:xfrm>
-          <a:prstGeom prst="rect">
-            <a:avLst/>
-          </a:prstGeom>
-          <a:noFill/>
-          <a:ln>
-            <a:noFill/>
-          </a:ln>
-        </p:spPr>
-        <p:txBody>
-          <a:bodyPr anchorCtr="0" anchor="t" bIns="0" lIns="0" spcFirstLastPara="1" rIns="0" wrap="square" tIns="0">
-            <a:spAutoFit/>
-          </a:bodyPr>
-          <a:lstStyle/>
-          <a:p>
-            <a:pPr indent="0" lvl="0" marL="0" marR="0" rtl="0" algn="l">
-              <a:lnSpc>
-                <a:spcPct val="110000"/>
-              </a:lnSpc>
-              <a:spcBef>
-                <a:spcPts val="0"/>
-              </a:spcBef>
-              <a:spcAft>
-                <a:spcPts val="0"/>
-              </a:spcAft>
-              <a:buNone/>
-            </a:pPr>
-            <a:r>
-              <a:rPr b="0" i="0" lang="en-US" sz="2400" u="none" cap="none" strike="noStrike">
-                <a:solidFill>
-                  <a:srgbClr val="000000"/>
-                </a:solidFill>
-                <a:latin typeface="Poppins"/>
-                <a:ea typeface="Poppins"/>
-                <a:cs typeface="Poppins"/>
-                <a:sym typeface="Poppins"/>
-              </a:rPr>
-              <a:t>$288K</a:t>
-            </a:r>
-            <a:endParaRPr/>
-          </a:p>
-        </p:txBody>
-      </p:sp>
-      <p:sp>
-        <p:nvSpPr>
-          <p:cNvPr id="327" name="Google Shape;327;p11"/>
-          <p:cNvSpPr txBox="1"/>
-          <p:nvPr/>
-        </p:nvSpPr>
-        <p:spPr>
-          <a:xfrm>
-            <a:off x="6949440" y="4343400"/>
-            <a:ext cx="10515600" cy="1463040"/>
-          </a:xfrm>
-          <a:prstGeom prst="rect">
-            <a:avLst/>
-          </a:prstGeom>
-          <a:noFill/>
-          <a:ln>
-            <a:noFill/>
-          </a:ln>
-        </p:spPr>
-        <p:txBody>
-          <a:bodyPr anchorCtr="0" anchor="t" bIns="0" lIns="0" spcFirstLastPara="1" rIns="0" wrap="square" tIns="0">
-            <a:spAutoFit/>
-          </a:bodyPr>
-          <a:lstStyle/>
-          <a:p>
-            <a:pPr indent="0" lvl="0" marL="0" marR="0" rtl="0" algn="l">
-              <a:lnSpc>
-                <a:spcPct val="110000"/>
-              </a:lnSpc>
-              <a:spcBef>
-                <a:spcPts val="0"/>
-              </a:spcBef>
-              <a:spcAft>
-                <a:spcPts val="0"/>
-              </a:spcAft>
-              <a:buNone/>
-            </a:pPr>
-            <a:r>
-              <a:rPr b="0" i="0" lang="en-US" sz="2200" u="none" cap="none" strike="noStrike">
-                <a:solidFill>
-                  <a:srgbClr val="434343"/>
-                </a:solidFill>
-                <a:latin typeface="Poppins"/>
-                <a:ea typeface="Poppins"/>
-                <a:cs typeface="Poppins"/>
-                <a:sym typeface="Poppins"/>
-              </a:rPr>
-              <a:t>Diners we send ($156K), tables booked ($54K) and area insights for chains ($78K). They pay for customers, not for ads. About $0.90 a diner sits under OpenTable’s $1.00 to $1.50, bookings are a quarter of Tabelog’s rate, and chains pay a quarter of Placer.ai’s.</a:t>
-            </a:r>
-            <a:endParaRPr/>
-          </a:p>
-        </p:txBody>
-      </p:sp>
-      <p:sp>
-        <p:nvSpPr>
-          <p:cNvPr id="328" name="Google Shape;328;p11"/>
-          <p:cNvSpPr/>
-          <p:nvPr/>
-        </p:nvSpPr>
-        <p:spPr>
-          <a:xfrm>
-            <a:off x="822960" y="6172200"/>
-            <a:ext cx="16642080" cy="10972"/>
-          </a:xfrm>
-          <a:prstGeom prst="rect">
-            <a:avLst/>
-          </a:prstGeom>
-          <a:solidFill>
-            <a:srgbClr val="D9D9D9"/>
-          </a:solidFill>
-          <a:ln>
-            <a:noFill/>
-          </a:ln>
-          <a:effectLst>
-            <a:outerShdw blurRad="40000" rotWithShape="0" dir="5400000" dist="23000">
-              <a:srgbClr val="000000">
-                <a:alpha val="34902"/>
-              </a:srgbClr>
-            </a:outerShdw>
-          </a:effectLst>
-        </p:spPr>
-        <p:txBody>
-          <a:bodyPr anchorCtr="0" anchor="ctr" bIns="45700" lIns="91425" spcFirstLastPara="1" rIns="91425" wrap="square" tIns="45700">
-            <a:noAutofit/>
-          </a:bodyPr>
-          <a:lstStyle/>
-          <a:p>
-            <a:pPr indent="0" lvl="0" marL="0" marR="0" rtl="0" algn="ctr">
-              <a:spcBef>
-                <a:spcPts val="0"/>
-              </a:spcBef>
-              <a:spcAft>
-                <a:spcPts val="0"/>
-              </a:spcAft>
-              <a:buNone/>
-            </a:pPr>
-            <a:r>
-              <a:t/>
-            </a:r>
-            <a:endParaRPr b="0" i="0" sz="1800" u="none" cap="none" strike="noStrike">
-              <a:solidFill>
-                <a:schemeClr val="dk1"/>
-              </a:solidFill>
-              <a:latin typeface="Calibri"/>
-              <a:ea typeface="Calibri"/>
-              <a:cs typeface="Calibri"/>
-              <a:sym typeface="Calibri"/>
-            </a:endParaRPr>
-          </a:p>
-        </p:txBody>
-      </p:sp>
-      <p:sp>
-        <p:nvSpPr>
-          <p:cNvPr id="329" name="Google Shape;329;p11"/>
-          <p:cNvSpPr txBox="1"/>
-          <p:nvPr/>
-        </p:nvSpPr>
-        <p:spPr>
-          <a:xfrm>
-            <a:off x="822960" y="6355080"/>
-            <a:ext cx="3931920" cy="548640"/>
-          </a:xfrm>
-          <a:prstGeom prst="rect">
-            <a:avLst/>
-          </a:prstGeom>
-          <a:noFill/>
-          <a:ln>
-            <a:noFill/>
-          </a:ln>
-        </p:spPr>
-        <p:txBody>
-          <a:bodyPr anchorCtr="0" anchor="t" bIns="0" lIns="0" spcFirstLastPara="1" rIns="0" wrap="square" tIns="0">
-            <a:spAutoFit/>
-          </a:bodyPr>
-          <a:lstStyle/>
-          <a:p>
-            <a:pPr indent="0" lvl="0" marL="0" marR="0" rtl="0" algn="l">
-              <a:lnSpc>
-                <a:spcPct val="110000"/>
-              </a:lnSpc>
-              <a:spcBef>
-                <a:spcPts val="0"/>
-              </a:spcBef>
-              <a:spcAft>
-                <a:spcPts val="0"/>
-              </a:spcAft>
-              <a:buNone/>
-            </a:pPr>
-            <a:r>
-              <a:rPr b="0" i="0" lang="en-US" sz="2400" u="none" cap="none" strike="noStrike">
-                <a:solidFill>
-                  <a:srgbClr val="000000"/>
-                </a:solidFill>
-                <a:latin typeface="Poppins"/>
-                <a:ea typeface="Poppins"/>
-                <a:cs typeface="Poppins"/>
-                <a:sym typeface="Poppins"/>
-              </a:rPr>
-              <a:t>Users</a:t>
-            </a:r>
-            <a:endParaRPr/>
-          </a:p>
-        </p:txBody>
-      </p:sp>
-      <p:sp>
-        <p:nvSpPr>
-          <p:cNvPr id="330" name="Google Shape;330;p11"/>
-          <p:cNvSpPr txBox="1"/>
-          <p:nvPr/>
-        </p:nvSpPr>
-        <p:spPr>
-          <a:xfrm>
-            <a:off x="4937760" y="6355080"/>
-            <a:ext cx="1737360" cy="548640"/>
-          </a:xfrm>
-          <a:prstGeom prst="rect">
-            <a:avLst/>
-          </a:prstGeom>
-          <a:noFill/>
-          <a:ln>
-            <a:noFill/>
-          </a:ln>
-        </p:spPr>
-        <p:txBody>
-          <a:bodyPr anchorCtr="0" anchor="t" bIns="0" lIns="0" spcFirstLastPara="1" rIns="0" wrap="square" tIns="0">
-            <a:spAutoFit/>
-          </a:bodyPr>
-          <a:lstStyle/>
-          <a:p>
-            <a:pPr indent="0" lvl="0" marL="0" marR="0" rtl="0" algn="l">
-              <a:lnSpc>
-                <a:spcPct val="110000"/>
-              </a:lnSpc>
-              <a:spcBef>
-                <a:spcPts val="0"/>
-              </a:spcBef>
-              <a:spcAft>
-                <a:spcPts val="0"/>
-              </a:spcAft>
-              <a:buNone/>
-            </a:pPr>
-            <a:r>
-              <a:rPr b="0" i="0" lang="en-US" sz="2400" u="none" cap="none" strike="noStrike">
-                <a:solidFill>
-                  <a:srgbClr val="000000"/>
-                </a:solidFill>
-                <a:latin typeface="Poppins"/>
-                <a:ea typeface="Poppins"/>
-                <a:cs typeface="Poppins"/>
-                <a:sym typeface="Poppins"/>
-              </a:rPr>
-              <a:t>$67K</a:t>
-            </a:r>
-            <a:endParaRPr/>
-          </a:p>
-        </p:txBody>
-      </p:sp>
-      <p:sp>
-        <p:nvSpPr>
-          <p:cNvPr id="331" name="Google Shape;331;p11"/>
-          <p:cNvSpPr txBox="1"/>
-          <p:nvPr/>
-        </p:nvSpPr>
-        <p:spPr>
-          <a:xfrm>
-            <a:off x="6949440" y="6355080"/>
-            <a:ext cx="10515600" cy="1463040"/>
-          </a:xfrm>
-          <a:prstGeom prst="rect">
-            <a:avLst/>
-          </a:prstGeom>
-          <a:noFill/>
-          <a:ln>
-            <a:noFill/>
-          </a:ln>
-        </p:spPr>
-        <p:txBody>
-          <a:bodyPr anchorCtr="0" anchor="t" bIns="0" lIns="0" spcFirstLastPara="1" rIns="0" wrap="square" tIns="0">
-            <a:spAutoFit/>
-          </a:bodyPr>
-          <a:lstStyle/>
-          <a:p>
-            <a:pPr indent="0" lvl="0" marL="0" marR="0" rtl="0" algn="l">
-              <a:lnSpc>
-                <a:spcPct val="110000"/>
-              </a:lnSpc>
-              <a:spcBef>
-                <a:spcPts val="0"/>
-              </a:spcBef>
-              <a:spcAft>
-                <a:spcPts val="0"/>
-              </a:spcAft>
-              <a:buNone/>
-            </a:pPr>
-            <a:r>
-              <a:rPr b="0" i="0" lang="en-US" sz="2200" u="none" cap="none" strike="noStrike">
-                <a:solidFill>
-                  <a:srgbClr val="434343"/>
-                </a:solidFill>
-                <a:latin typeface="Poppins"/>
-                <a:ea typeface="Poppins"/>
-                <a:cs typeface="Poppins"/>
-                <a:sym typeface="Poppins"/>
-              </a:rPr>
-              <a:t>The optional $5 a month membership: extras on top of a free app, such as taste match with friends. About 0.3% pay, the same share as Tabelog’s users.</a:t>
-            </a:r>
-            <a:endParaRPr/>
-          </a:p>
-        </p:txBody>
-      </p:sp>
-      <p:sp>
-        <p:nvSpPr>
-          <p:cNvPr id="332" name="Google Shape;332;p11"/>
-          <p:cNvSpPr/>
-          <p:nvPr/>
-        </p:nvSpPr>
-        <p:spPr>
-          <a:xfrm>
-            <a:off x="822960" y="7772400"/>
-            <a:ext cx="16642080" cy="10972"/>
-          </a:xfrm>
-          <a:prstGeom prst="rect">
-            <a:avLst/>
-          </a:prstGeom>
-          <a:solidFill>
-            <a:srgbClr val="D9D9D9"/>
-          </a:solidFill>
-          <a:ln>
-            <a:noFill/>
-          </a:ln>
-          <a:effectLst>
-            <a:outerShdw blurRad="40000" rotWithShape="0" dir="5400000" dist="23000">
-              <a:srgbClr val="000000">
-                <a:alpha val="34902"/>
-              </a:srgbClr>
-            </a:outerShdw>
-          </a:effectLst>
-        </p:spPr>
-        <p:txBody>
-          <a:bodyPr anchorCtr="0" anchor="ctr" bIns="45700" lIns="91425" spcFirstLastPara="1" rIns="91425" wrap="square" tIns="45700">
-            <a:noAutofit/>
-          </a:bodyPr>
-          <a:lstStyle/>
-          <a:p>
-            <a:pPr indent="0" lvl="0" marL="0" marR="0" rtl="0" algn="ctr">
-              <a:spcBef>
-                <a:spcPts val="0"/>
-              </a:spcBef>
-              <a:spcAft>
-                <a:spcPts val="0"/>
-              </a:spcAft>
-              <a:buNone/>
-            </a:pPr>
-            <a:r>
-              <a:t/>
-            </a:r>
-            <a:endParaRPr b="0" i="0" sz="1800" u="none" cap="none" strike="noStrike">
-              <a:solidFill>
-                <a:schemeClr val="dk1"/>
-              </a:solidFill>
-              <a:latin typeface="Calibri"/>
-              <a:ea typeface="Calibri"/>
-              <a:cs typeface="Calibri"/>
-              <a:sym typeface="Calibri"/>
-            </a:endParaRPr>
           </a:p>
         </p:txBody>
       </p:sp>

</xml_diff>